<commit_message>
Add gemma_qlora_task_and_results.pptx deck focusing on dataset, tasks, approaches, and empirical takeaways
</commit_message>
<xml_diff>
--- a/docs/gemma_qlora_core_concepts.pptx
+++ b/docs/gemma_qlora_core_concepts.pptx
@@ -3840,7 +3840,7 @@
                 </a:solidFill>
                 <a:latin typeface="Calibri"/>
               </a:rPr>
-              <a:t>• Uncalibrated Output: </a:t>
+              <a:t>• Accuracy Ceiling: </a:t>
             </a:r>
             <a:r>
               <a:rPr b="0" sz="1500">
@@ -3849,7 +3849,7 @@
                 </a:solidFill>
                 <a:latin typeface="Calibri"/>
               </a:rPr>
-              <a:t>Zero-shot struggles with multi-label sets and out-of-domain posts.</a:t>
+              <a:t>Zero-shot reaches 0.587 C2 F1; even 10-shot plateaus at 0.703 F1.</a:t>
             </a:r>
           </a:p>
           <a:p>
@@ -3868,7 +3868,7 @@
                 </a:solidFill>
                 <a:latin typeface="Calibri"/>
               </a:rPr>
-              <a:t>• Slow Few-Shot: </a:t>
+              <a:t>• High Token Cost: </a:t>
             </a:r>
             <a:r>
               <a:rPr b="0" sz="1500">
@@ -3877,7 +3877,7 @@
                 </a:solidFill>
                 <a:latin typeface="Calibri"/>
               </a:rPr>
-              <a:t>10-shot adds ~1,500 tokens to every query (2x slower inference).</a:t>
+              <a:t>10-shot prepends ~1,760 tokens per document (2.7x more tokens).</a:t>
             </a:r>
           </a:p>
         </p:txBody>
@@ -4238,7 +4238,7 @@
                 </a:solidFill>
                 <a:latin typeface="Calibri"/>
               </a:rPr>
-              <a:t>• +26.7 F1 over 10-Shot: </a:t>
+              <a:t>• +14.5 F1 over 10-Shot: </a:t>
             </a:r>
             <a:r>
               <a:rPr b="0" sz="1500">
@@ -4247,7 +4247,7 @@
                 </a:solidFill>
                 <a:latin typeface="Calibri"/>
               </a:rPr>
-              <a:t>Jumps from 0.258 (0-shot) &amp; 0.453 (10-shot) to 0.720 Micro-F1.</a:t>
+              <a:t>Jumps from 0.587 (0-shot) &amp; 0.703 (10-shot) to 0.849 Micro-F1.</a:t>
             </a:r>
           </a:p>
           <a:p>
@@ -5401,7 +5401,7 @@
               </a:defRPr>
             </a:pPr>
             <a:r>
-              <a:t>Tokens : &lt;bos&gt; &lt;start_of_turn&gt;user ... [~860 Prompt Tokens] ... &lt;start_of_turn&gt;model\n {"labels": ["Zugfahrt:negative"]} &lt;end_of_turn&gt;</a:t>
+              <a:t>Tokens : &lt;bos&gt; &lt;start_of_turn&gt;user ... [~660 Prompt Tokens] ... &lt;start_of_turn&gt;model\n {"labels": ["Zugfahrt:negative"]} &lt;end_of_turn&gt;</a:t>
             </a:r>
           </a:p>
           <a:p>
@@ -5578,7 +5578,7 @@
               </a:defRPr>
             </a:pPr>
             <a:r>
-              <a:t>The 50:1 Token Asymmetry Problem</a:t>
+              <a:t>The 35:1 Token Asymmetry Problem</a:t>
             </a:r>
           </a:p>
           <a:p>
@@ -5597,7 +5597,7 @@
                 </a:solidFill>
                 <a:latin typeface="Calibri"/>
               </a:rPr>
-              <a:t>• Long Prompt (~860 tokens): </a:t>
+              <a:t>• Long Prompt (~660 tokens): </a:t>
             </a:r>
             <a:r>
               <a:rPr b="0" sz="1500">
@@ -8174,7 +8174,7 @@
                         </a:defRPr>
                       </a:pPr>
                       <a:r>
-                        <a:t>0.7204 (100% Valid JSON)</a:t>
+                        <a:t>0.8486 Strict / 0.7370 Java</a:t>
                       </a:r>
                     </a:p>
                   </a:txBody>
@@ -8198,7 +8198,7 @@
                         </a:defRPr>
                       </a:pPr>
                       <a:r>
-                        <a:t>0.7191 (100% Valid JSON)</a:t>
+                        <a:t>0.8360 Strict / 0.7182 Java</a:t>
                       </a:r>
                     </a:p>
                   </a:txBody>
@@ -8365,7 +8365,7 @@
                 </a:solidFill>
                 <a:latin typeface="Calibri"/>
               </a:rPr>
-              <a:t>Switch seamlessly between 4-bit QLoRA (2.9 GB VRAM) and 16-bit LoRA (7.2 GB VRAM) with identical ~0.720 F1.</a:t>
+              <a:t>Switch seamlessly between 4-bit QLoRA (2.9 GB VRAM) and 16-bit LoRA (7.2 GB VRAM) with &lt;1.3% F1 difference.</a:t>
             </a:r>
           </a:p>
         </p:txBody>
@@ -8598,7 +8598,7 @@
                         </a:defRPr>
                       </a:pPr>
                       <a:r>
-                        <a:t>Method</a:t>
+                        <a:t>Method (test_syn)</a:t>
                       </a:r>
                     </a:p>
                   </a:txBody>
@@ -8646,7 +8646,7 @@
                         </a:defRPr>
                       </a:pPr>
                       <a:r>
-                        <a:t>C1 Micro-F1</a:t>
+                        <a:t>C1 Strict F1</a:t>
                       </a:r>
                     </a:p>
                   </a:txBody>
@@ -8670,7 +8670,7 @@
                         </a:defRPr>
                       </a:pPr>
                       <a:r>
-                        <a:t>C2 Micro-F1</a:t>
+                        <a:t>C2 Strict F1</a:t>
                       </a:r>
                     </a:p>
                   </a:txBody>
@@ -8720,7 +8720,7 @@
                         </a:defRPr>
                       </a:pPr>
                       <a:r>
-                        <a:t>91.4%</a:t>
+                        <a:t>98.1%</a:t>
                       </a:r>
                     </a:p>
                   </a:txBody>
@@ -8744,7 +8744,7 @@
                         </a:defRPr>
                       </a:pPr>
                       <a:r>
-                        <a:t>0.312</a:t>
+                        <a:t>0.555</a:t>
                       </a:r>
                     </a:p>
                   </a:txBody>
@@ -8768,7 +8768,7 @@
                         </a:defRPr>
                       </a:pPr>
                       <a:r>
-                        <a:t>0.214</a:t>
+                        <a:t>0.464</a:t>
                       </a:r>
                     </a:p>
                   </a:txBody>
@@ -8818,7 +8818,7 @@
                         </a:defRPr>
                       </a:pPr>
                       <a:r>
-                        <a:t>95.8%</a:t>
+                        <a:t>99.7%</a:t>
                       </a:r>
                     </a:p>
                   </a:txBody>
@@ -8842,7 +8842,7 @@
                         </a:defRPr>
                       </a:pPr>
                       <a:r>
-                        <a:t>0.368</a:t>
+                        <a:t>0.668</a:t>
                       </a:r>
                     </a:p>
                   </a:txBody>
@@ -8866,7 +8866,7 @@
                         </a:defRPr>
                       </a:pPr>
                       <a:r>
-                        <a:t>0.258</a:t>
+                        <a:t>0.587</a:t>
                       </a:r>
                     </a:p>
                   </a:txBody>
@@ -8916,7 +8916,7 @@
                         </a:defRPr>
                       </a:pPr>
                       <a:r>
-                        <a:t>99.4%</a:t>
+                        <a:t>100.0%</a:t>
                       </a:r>
                     </a:p>
                   </a:txBody>
@@ -8940,7 +8940,7 @@
                         </a:defRPr>
                       </a:pPr>
                       <a:r>
-                        <a:t>0.569</a:t>
+                        <a:t>0.767</a:t>
                       </a:r>
                     </a:p>
                   </a:txBody>
@@ -8964,7 +8964,7 @@
                         </a:defRPr>
                       </a:pPr>
                       <a:r>
-                        <a:t>0.453</a:t>
+                        <a:t>0.703</a:t>
                       </a:r>
                     </a:p>
                   </a:txBody>
@@ -9038,7 +9038,7 @@
                         </a:defRPr>
                       </a:pPr>
                       <a:r>
-                        <a:t>0.781</a:t>
+                        <a:t>0.882</a:t>
                       </a:r>
                     </a:p>
                   </a:txBody>
@@ -9062,7 +9062,7 @@
                         </a:defRPr>
                       </a:pPr>
                       <a:r>
-                        <a:t>0.720</a:t>
+                        <a:t>0.849</a:t>
                       </a:r>
                     </a:p>
                   </a:txBody>
@@ -9136,7 +9136,7 @@
                         </a:defRPr>
                       </a:pPr>
                       <a:r>
-                        <a:t>0.779</a:t>
+                        <a:t>0.873</a:t>
                       </a:r>
                     </a:p>
                   </a:txBody>
@@ -9160,7 +9160,7 @@
                         </a:defRPr>
                       </a:pPr>
                       <a:r>
-                        <a:t>0.719</a:t>
+                        <a:t>0.836</a:t>
                       </a:r>
                     </a:p>
                   </a:txBody>
@@ -9327,7 +9327,7 @@
                 </a:solidFill>
                 <a:latin typeface="Calibri"/>
               </a:rPr>
-              <a:t>0.512 F1 (already beats 10-shot!)</a:t>
+              <a:t>0.648 F1 (beats 2-shot prompting)</a:t>
             </a:r>
           </a:p>
           <a:p>
@@ -9355,7 +9355,7 @@
                 </a:solidFill>
                 <a:latin typeface="Calibri"/>
               </a:rPr>
-              <a:t>0.609 F1 (~5 min on Colab L4)</a:t>
+              <a:t>0.701 F1 (matches 10-shot in 1.6 min)</a:t>
             </a:r>
           </a:p>
           <a:p>
@@ -9374,7 +9374,7 @@
                 </a:solidFill>
                 <a:latin typeface="Calibri"/>
               </a:rPr>
-              <a:t>• 5,000 docs (25.7%): </a:t>
+              <a:t>• 2,000 docs (10.3%): </a:t>
             </a:r>
             <a:r>
               <a:rPr b="0" sz="1500">
@@ -9383,7 +9383,7 @@
                 </a:solidFill>
                 <a:latin typeface="Calibri"/>
               </a:rPr>
-              <a:t>0.684 F1 (95% of full performance)</a:t>
+              <a:t>0.722 F1 (surpasses 10-shot)</a:t>
             </a:r>
           </a:p>
           <a:p>
@@ -9411,7 +9411,7 @@
                 </a:solidFill>
                 <a:latin typeface="Calibri"/>
               </a:rPr>
-              <a:t>0.719 F1 (full convergence)</a:t>
+              <a:t>0.836 F1 (+13.3 F1 over 10-shot)</a:t>
             </a:r>
           </a:p>
         </p:txBody>
@@ -9568,7 +9568,7 @@
                 </a:solidFill>
                 <a:latin typeface="Calibri"/>
               </a:rPr>
-              <a:t>Completion-masked JSON SFT + rank-16 LoRA + 4-bit NF4 quantization delivers a +26.7 F1 gain over 10-shot prompting in under 3 GB of GPU memory.</a:t>
+              <a:t>Completion-masked JSON SFT + rank-16 LoRA + 4-bit NF4 quantization delivers +14.5 F1 over 10-shot prompting in under 3 GB of GPU memory.</a:t>
             </a:r>
           </a:p>
         </p:txBody>

</xml_diff>